<commit_message>
Fix wrong mental-health figure and oversimplified constraint claim (v3)
Slide 8 claimed mental-health staff need would exceed 6x current
capacity; the actual pipeline output is 101%, not 600%+. The
headline also overstated the finding as "workforce, not budget" -
the real result is that pharmacy staff, mental-health staff, and the
consumables budget all saturate near 100% simultaneously, while
doctors and nurses retain slack. Corrected on this slide and on the
takeaways slide, which repeated the same oversimplification.
</commit_message>
<xml_diff>
--- a/reports/Defining_Health_Benefits_Package_in_Senegal_Presentation_v3.pptx
+++ b/reports/Defining_Health_Benefits_Package_in_Senegal_Presentation_v3.pptx
@@ -957,7 +957,7 @@
           <a:p>
             <a:r>
               <a:rPr lang="en-US" dirty="0"/>
-              <a:t>Three takeaways: cost-effectiveness alone isn't enough, workforce is the real constraint, and efficiency and equity don't always agree - which is a decision for the group, not something the model should decide silently.</a:t>
+              <a:t>Three takeaways: cost-effectiveness alone isn't enough, several resources bind together rather than one single bottleneck, and efficiency and equity don't always agree - which is a decision for the group, not something the model should decide silently.</a:t>
             </a:r>
             <a:endParaRPr lang="en-US" dirty="0"/>
           </a:p>
@@ -1749,7 +1749,7 @@
           <a:p>
             <a:r>
               <a:rPr lang="en-US" dirty="0"/>
-              <a:t>The pattern is clear even before we have Senegal-specific staffing numbers: the budget saturates first, general medical staff retain slack, and mental health is the cadre most squeezed out. I want to be explicit that the workforce data behind this is still a reference-country dataset - the pattern is informative, the exact magnitude is not yet locally validated.</a:t>
+              <a:t>The pattern is clear even before we have Senegal-specific staffing numbers: it isn't one resource that binds, it's three at once - pharmacy staff, mental-health staff, and the consumables budget all saturate near 100% together, while doctors and nurses retain real slack. I want to be explicit that the workforce data behind this is still a reference-country dataset - the pattern is informative, the exact magnitude is not yet locally validated.</a:t>
             </a:r>
             <a:endParaRPr lang="en-US" dirty="0"/>
           </a:p>
@@ -3437,7 +3437,7 @@
                 <a:ea typeface="Arial" pitchFamily="34" charset="-122"/>
                 <a:cs typeface="Arial" pitchFamily="34" charset="-120"/>
               </a:rPr>
-              <a:t>Workforce, not budget, is the binding constraint once real limits are applied</a:t>
+              <a:t>Several resources bind at once - pharmacy staff, mental-health staff, and the budget - while doctors and nurses keep slack</a:t>
             </a:r>
             <a:endParaRPr lang="en-US" sz="1650" dirty="0"/>
           </a:p>
@@ -5504,7 +5504,7 @@
                 <a:ea typeface="Arial" pitchFamily="34" charset="-122"/>
                 <a:cs typeface="Arial" pitchFamily="34" charset="-120"/>
               </a:rPr>
-              <a:t>Workforce capacity, not the budget, is what actually limits the package.</a:t>
+              <a:t>Pharmacy staff, mental-health staff, and the budget bind together - doctors and nurses have slack.</a:t>
             </a:r>
             <a:endParaRPr lang="en-US" sz="2300" dirty="0"/>
           </a:p>
@@ -5571,7 +5571,7 @@
                 <a:ea typeface="Arial" pitchFamily="34" charset="-122"/>
                 <a:cs typeface="Arial" pitchFamily="34" charset="-120"/>
               </a:rPr>
-              <a:t>Without any constraint, mental-health staff need would exceed 6x current capacity</a:t>
+              <a:t>Without any constraint, pharmaceutical-staff need would exceed 2x current capacity (214%); mental-health need would exceed it too (101%)</a:t>
             </a:r>
             <a:endParaRPr lang="en-US" sz="1400" dirty="0"/>
           </a:p>
@@ -5592,7 +5592,7 @@
                 <a:ea typeface="Arial" pitchFamily="34" charset="-122"/>
                 <a:cs typeface="Arial" pitchFamily="34" charset="-120"/>
               </a:rPr>
-              <a:t>Once applied, the budget saturates at 100%: it is the binding limit in this scenario</a:t>
+              <a:t>Once applied, pharmacy, mental health, and the consumables budget all saturate near 100% at the same time</a:t>
             </a:r>
             <a:endParaRPr lang="en-US" sz="1400" dirty="0"/>
           </a:p>
@@ -5613,7 +5613,7 @@
                 <a:ea typeface="Arial" pitchFamily="34" charset="-122"/>
                 <a:cs typeface="Arial" pitchFamily="34" charset="-120"/>
               </a:rPr>
-              <a:t>General medical staff keep slack; mental-health services are almost entirely crowded out</a:t>
+              <a:t>Doctors (49%) and nurses (22%) keep real slack - they are not the binding resource</a:t>
             </a:r>
             <a:endParaRPr lang="en-US" sz="1400" dirty="0"/>
           </a:p>

</xml_diff>